<commit_message>
Add real session photos to the Class 4 practice-session slides
Co-Authored-By: Claude Fable 5 <noreply@anthropic.com>
Claude-Session: https://claude.ai/code/session_01GSMZNrEY1m6jmPVZHt63bA
</commit_message>
<xml_diff>
--- a/content/presentations/HPR-Class4-Practice-Sessions.pptx
+++ b/content/presentations/HPR-Class4-Practice-Sessions.pptx
@@ -3123,12 +3123,19 @@
           </a:p>
         </p:txBody>
       </p:sp>
-      <p:sp>
-        <p:nvSpPr>
-          <p:cNvPr id="10" name="Shape 7"/>
-          <p:cNvSpPr/>
-          <p:nvPr/>
-        </p:nvSpPr>
+      <p:pic>
+        <p:nvPicPr>
+          <p:cNvPr id="10" name="Image 1" descr="/tmp/claude-0/-home-user-tribal-cowboy-webhook/9ba9e801-9603-5165-907c-67d024c96ac6/scratchpad/session1-photo-small.jpg">    </p:cNvPr>
+          <p:cNvPicPr>
+            <a:picLocks noChangeAspect="1"/>
+          </p:cNvPicPr>
+          <p:nvPr/>
+        </p:nvPicPr>
+        <p:blipFill>
+          <a:blip r:embed="rId2"/>
+          <a:srcRect l="0" r="0" t="0" b="0"/>
+          <a:stretch/>
+        </p:blipFill>
         <p:spPr>
           <a:xfrm>
             <a:off x="5486400" y="960120"/>
@@ -3137,90 +3144,38 @@
           <a:prstGeom prst="rect">
             <a:avLst/>
           </a:prstGeom>
+        </p:spPr>
+      </p:pic>
+      <p:sp>
+        <p:nvSpPr>
+          <p:cNvPr id="11" name="Shape 7"/>
+          <p:cNvSpPr/>
+          <p:nvPr/>
+        </p:nvSpPr>
+        <p:spPr>
+          <a:xfrm>
+            <a:off x="5486400" y="960120"/>
+            <a:ext cx="3108960" cy="3566160"/>
+          </a:xfrm>
+          <a:prstGeom prst="rect">
+            <a:avLst/>
+          </a:prstGeom>
           <a:solidFill>
-            <a:srgbClr val="FAF4EA"/>
+            <a:srgbClr val="D4A843">
+              <a:alpha val="0"/>
+            </a:srgbClr>
           </a:solidFill>
-          <a:ln w="15875">
+          <a:ln w="19050">
             <a:solidFill>
               <a:srgbClr val="D4A843"/>
             </a:solidFill>
-            <a:prstDash val="dash"/>
+            <a:prstDash val="solid"/>
           </a:ln>
         </p:spPr>
       </p:sp>
       <p:sp>
         <p:nvSpPr>
-          <p:cNvPr id="11" name="Text 8"/>
-          <p:cNvSpPr/>
-          <p:nvPr/>
-        </p:nvSpPr>
-        <p:spPr>
-          <a:xfrm>
-            <a:off x="5715000" y="960120"/>
-            <a:ext cx="2651760" cy="3566160"/>
-          </a:xfrm>
-          <a:prstGeom prst="rect">
-            <a:avLst/>
-          </a:prstGeom>
-          <a:noFill/>
-          <a:ln/>
-        </p:spPr>
-        <p:txBody>
-          <a:bodyPr wrap="square" lIns="0" tIns="0" rIns="0" bIns="0" rtlCol="0" anchor="ctr"/>
-          <a:lstStyle/>
-          <a:p>
-            <a:pPr algn="ctr" indent="0" marL="0">
-              <a:buNone/>
-            </a:pPr>
-            <a:r>
-              <a:rPr lang="en-US" sz="1200" b="1" spc="300" kern="0" dirty="0">
-                <a:solidFill>
-                  <a:srgbClr val="D4A843"/>
-                </a:solidFill>
-                <a:latin typeface="Trebuchet MS" pitchFamily="34" charset="0"/>
-                <a:ea typeface="Trebuchet MS" pitchFamily="34" charset="-122"/>
-                <a:cs typeface="Trebuchet MS" pitchFamily="34" charset="-120"/>
-              </a:rPr>
-              <a:t>PHOTO</a:t>
-            </a:r>
-            <a:endParaRPr lang="en-US" sz="1200" dirty="0"/>
-          </a:p>
-          <a:p>
-            <a:pPr algn="ctr" indent="0" marL="0">
-              <a:buNone/>
-            </a:pPr>
-            <a:r>
-              <a:rPr lang="en-US" sz="600" dirty="0">
-                <a:solidFill>
-                  <a:srgbClr val="000000"/>
-                </a:solidFill>
-              </a:rPr>
-              <a:t> </a:t>
-            </a:r>
-            <a:endParaRPr lang="en-US" sz="1200" dirty="0"/>
-          </a:p>
-          <a:p>
-            <a:pPr algn="ctr" indent="0" marL="0">
-              <a:buNone/>
-            </a:pPr>
-            <a:r>
-              <a:rPr lang="en-US" sz="950" i="1" dirty="0">
-                <a:solidFill>
-                  <a:srgbClr val="8A7560"/>
-                </a:solidFill>
-                <a:latin typeface="Trebuchet MS" pitchFamily="34" charset="0"/>
-                <a:ea typeface="Trebuchet MS" pitchFamily="34" charset="-122"/>
-                <a:cs typeface="Trebuchet MS" pitchFamily="34" charset="-120"/>
-              </a:rPr>
-              <a:t>Drop your favorite shot from this session here — the horse and reader together beats a posed smile</a:t>
-            </a:r>
-            <a:endParaRPr lang="en-US" sz="1200" dirty="0"/>
-          </a:p>
-        </p:txBody>
-      </p:sp>
-      <p:sp>
-        <p:nvSpPr>
-          <p:cNvPr id="12" name="Shape 9"/>
+          <p:cNvPr id="12" name="Shape 8"/>
           <p:cNvSpPr/>
           <p:nvPr/>
         </p:nvSpPr>
@@ -3243,7 +3198,7 @@
       </p:sp>
       <p:sp>
         <p:nvSpPr>
-          <p:cNvPr id="13" name="Text 10"/>
+          <p:cNvPr id="13" name="Text 9"/>
           <p:cNvSpPr/>
           <p:nvPr/>
         </p:nvSpPr>
@@ -3282,7 +3237,7 @@
       </p:sp>
       <p:sp>
         <p:nvSpPr>
-          <p:cNvPr id="14" name="Text 11"/>
+          <p:cNvPr id="14" name="Text 10"/>
           <p:cNvSpPr/>
           <p:nvPr/>
         </p:nvSpPr>
@@ -4236,12 +4191,19 @@
           </a:p>
         </p:txBody>
       </p:sp>
-      <p:sp>
-        <p:nvSpPr>
-          <p:cNvPr id="10" name="Shape 7"/>
-          <p:cNvSpPr/>
-          <p:nvPr/>
-        </p:nvSpPr>
+      <p:pic>
+        <p:nvPicPr>
+          <p:cNvPr id="10" name="Image 1" descr="/tmp/claude-0/-home-user-tribal-cowboy-webhook/9ba9e801-9603-5165-907c-67d024c96ac6/scratchpad/session2-photo-small.jpg">    </p:cNvPr>
+          <p:cNvPicPr>
+            <a:picLocks noChangeAspect="1"/>
+          </p:cNvPicPr>
+          <p:nvPr/>
+        </p:nvPicPr>
+        <p:blipFill>
+          <a:blip r:embed="rId2"/>
+          <a:srcRect l="0" r="0" t="0" b="0"/>
+          <a:stretch/>
+        </p:blipFill>
         <p:spPr>
           <a:xfrm>
             <a:off x="5486400" y="960120"/>
@@ -4250,90 +4212,38 @@
           <a:prstGeom prst="rect">
             <a:avLst/>
           </a:prstGeom>
+        </p:spPr>
+      </p:pic>
+      <p:sp>
+        <p:nvSpPr>
+          <p:cNvPr id="11" name="Shape 7"/>
+          <p:cNvSpPr/>
+          <p:nvPr/>
+        </p:nvSpPr>
+        <p:spPr>
+          <a:xfrm>
+            <a:off x="5486400" y="960120"/>
+            <a:ext cx="3108960" cy="3566160"/>
+          </a:xfrm>
+          <a:prstGeom prst="rect">
+            <a:avLst/>
+          </a:prstGeom>
           <a:solidFill>
-            <a:srgbClr val="FAF4EA"/>
+            <a:srgbClr val="D4A843">
+              <a:alpha val="0"/>
+            </a:srgbClr>
           </a:solidFill>
-          <a:ln w="15875">
+          <a:ln w="19050">
             <a:solidFill>
               <a:srgbClr val="D4A843"/>
             </a:solidFill>
-            <a:prstDash val="dash"/>
+            <a:prstDash val="solid"/>
           </a:ln>
         </p:spPr>
       </p:sp>
       <p:sp>
         <p:nvSpPr>
-          <p:cNvPr id="11" name="Text 8"/>
-          <p:cNvSpPr/>
-          <p:nvPr/>
-        </p:nvSpPr>
-        <p:spPr>
-          <a:xfrm>
-            <a:off x="5715000" y="960120"/>
-            <a:ext cx="2651760" cy="3566160"/>
-          </a:xfrm>
-          <a:prstGeom prst="rect">
-            <a:avLst/>
-          </a:prstGeom>
-          <a:noFill/>
-          <a:ln/>
-        </p:spPr>
-        <p:txBody>
-          <a:bodyPr wrap="square" lIns="0" tIns="0" rIns="0" bIns="0" rtlCol="0" anchor="ctr"/>
-          <a:lstStyle/>
-          <a:p>
-            <a:pPr algn="ctr" indent="0" marL="0">
-              <a:buNone/>
-            </a:pPr>
-            <a:r>
-              <a:rPr lang="en-US" sz="1200" b="1" spc="300" kern="0" dirty="0">
-                <a:solidFill>
-                  <a:srgbClr val="D4A843"/>
-                </a:solidFill>
-                <a:latin typeface="Trebuchet MS" pitchFamily="34" charset="0"/>
-                <a:ea typeface="Trebuchet MS" pitchFamily="34" charset="-122"/>
-                <a:cs typeface="Trebuchet MS" pitchFamily="34" charset="-120"/>
-              </a:rPr>
-              <a:t>PHOTO</a:t>
-            </a:r>
-            <a:endParaRPr lang="en-US" sz="1200" dirty="0"/>
-          </a:p>
-          <a:p>
-            <a:pPr algn="ctr" indent="0" marL="0">
-              <a:buNone/>
-            </a:pPr>
-            <a:r>
-              <a:rPr lang="en-US" sz="600" dirty="0">
-                <a:solidFill>
-                  <a:srgbClr val="000000"/>
-                </a:solidFill>
-              </a:rPr>
-              <a:t> </a:t>
-            </a:r>
-            <a:endParaRPr lang="en-US" sz="1200" dirty="0"/>
-          </a:p>
-          <a:p>
-            <a:pPr algn="ctr" indent="0" marL="0">
-              <a:buNone/>
-            </a:pPr>
-            <a:r>
-              <a:rPr lang="en-US" sz="950" i="1" dirty="0">
-                <a:solidFill>
-                  <a:srgbClr val="8A7560"/>
-                </a:solidFill>
-                <a:latin typeface="Trebuchet MS" pitchFamily="34" charset="0"/>
-                <a:ea typeface="Trebuchet MS" pitchFamily="34" charset="-122"/>
-                <a:cs typeface="Trebuchet MS" pitchFamily="34" charset="-120"/>
-              </a:rPr>
-              <a:t>Drop your favorite shot from this session here — the horse and reader together beats a posed smile</a:t>
-            </a:r>
-            <a:endParaRPr lang="en-US" sz="1200" dirty="0"/>
-          </a:p>
-        </p:txBody>
-      </p:sp>
-      <p:sp>
-        <p:nvSpPr>
-          <p:cNvPr id="12" name="Shape 9"/>
+          <p:cNvPr id="12" name="Shape 8"/>
           <p:cNvSpPr/>
           <p:nvPr/>
         </p:nvSpPr>
@@ -4356,7 +4266,7 @@
       </p:sp>
       <p:sp>
         <p:nvSpPr>
-          <p:cNvPr id="13" name="Text 10"/>
+          <p:cNvPr id="13" name="Text 9"/>
           <p:cNvSpPr/>
           <p:nvPr/>
         </p:nvSpPr>
@@ -4395,7 +4305,7 @@
       </p:sp>
       <p:sp>
         <p:nvSpPr>
-          <p:cNvPr id="14" name="Text 11"/>
+          <p:cNvPr id="14" name="Text 10"/>
           <p:cNvSpPr/>
           <p:nvPr/>
         </p:nvSpPr>

</xml_diff>

<commit_message>
Fill in Word Racer as the Session 1 activity
Session 1 slides now carry the Word Racer lesson: cone weave with CVC
words out and Magic E words back, plus the silent-E concept callout
and matching speaker notes.

Co-Authored-By: Claude Fable 5 <noreply@anthropic.com>
Claude-Session: https://claude.ai/code/session_01GSMZNrEY1m6jmPVZHt63bA
</commit_message>
<xml_diff>
--- a/content/presentations/HPR-Class4-Practice-Sessions.pptx
+++ b/content/presentations/HPR-Class4-Practice-Sessions.pptx
@@ -686,7 +686,7 @@
           <a:p>
             <a:r>
               <a:rPr lang="en-US" dirty="0"/>
-              <a:t>Walk the class through session 1 in about a minute: the lesson you picked, why it looked fun, and what actually happened. Let the photo do half the talking.</a:t>
+              <a:t>Walk the class through Word Racer in about a minute: cones in a weaving pattern, CVC words facing the start (cap, kit, hop), Magic E versions on the back (cape, kite, hope). Down the line reading short vowels, turn around, back up the line reading long ones. Accuracy before speed — with more kids it runs as a relay. The pony sets the pace, which keeps her from rushing the words. Then share what actually happened in your session.</a:t>
             </a:r>
             <a:endParaRPr lang="en-US" dirty="0"/>
           </a:p>
@@ -2251,7 +2251,7 @@
                 <a:ea typeface="Georgia" pitchFamily="34" charset="-122"/>
                 <a:cs typeface="Georgia" pitchFamily="34" charset="-120"/>
               </a:rPr>
-              <a:t>[ Lesson name from the HPR curriculum ]</a:t>
+              <a:t>Word Racer — CVC words &amp; Magic E</a:t>
             </a:r>
             <a:endParaRPr lang="en-US" sz="900" dirty="0"/>
           </a:p>
@@ -2939,7 +2939,7 @@
                 <a:ea typeface="Georgia" pitchFamily="34" charset="-122"/>
                 <a:cs typeface="Georgia" pitchFamily="34" charset="-120"/>
               </a:rPr>
-              <a:t>Session 1: [ Lesson Name ]</a:t>
+              <a:t>Session 1: Word Racer</a:t>
             </a:r>
             <a:endParaRPr lang="en-US" sz="2400" dirty="0"/>
           </a:p>
@@ -2968,13 +2968,13 @@
           <a:p>
             <a:pPr marL="177800" indent="-177800">
               <a:spcAft>
-                <a:spcPts val="1000"/>
+                <a:spcPts val="800"/>
               </a:spcAft>
               <a:buSzPct val="100000"/>
               <a:buChar char="•"/>
             </a:pPr>
             <a:r>
-              <a:rPr lang="en-US" sz="1250" dirty="0">
+              <a:rPr lang="en-US" sz="1200" dirty="0">
                 <a:solidFill>
                   <a:srgbClr val="574838"/>
                 </a:solidFill>
@@ -2982,20 +2982,20 @@
                 <a:ea typeface="Trebuchet MS" pitchFamily="34" charset="-122"/>
                 <a:cs typeface="Trebuchet MS" pitchFamily="34" charset="-120"/>
               </a:rPr>
-              <a:t>[ How the session opened — meeting the horse, settling in ]</a:t>
-            </a:r>
-            <a:endParaRPr lang="en-US" sz="1250" dirty="0"/>
+              <a:t>Cones set in a weaving pattern, a word card on each side — a CVC word facing the start (cap, kit, hop), its Magic E partner on the back (cape, kite, hope)</a:t>
+            </a:r>
+            <a:endParaRPr lang="en-US" sz="1200" dirty="0"/>
           </a:p>
           <a:p>
             <a:pPr marL="177800" indent="-177800">
               <a:spcAft>
-                <a:spcPts val="1000"/>
+                <a:spcPts val="800"/>
               </a:spcAft>
               <a:buSzPct val="100000"/>
               <a:buChar char="•"/>
             </a:pPr>
             <a:r>
-              <a:rPr lang="en-US" sz="1250" dirty="0">
+              <a:rPr lang="en-US" sz="1200" dirty="0">
                 <a:solidFill>
                   <a:srgbClr val="574838"/>
                 </a:solidFill>
@@ -3003,9 +3003,9 @@
                 <a:ea typeface="Trebuchet MS" pitchFamily="34" charset="-122"/>
                 <a:cs typeface="Trebuchet MS" pitchFamily="34" charset="-120"/>
               </a:rPr>
-              <a:t>[ The main activity — what the child did with the horse and the reading task ]</a:t>
-            </a:r>
-            <a:endParaRPr lang="en-US" sz="1250" dirty="0"/>
+              <a:t>She picked her pony partner, then wove through the cones on the lead line, reading each short-vowel word out loud on the way down</a:t>
+            </a:r>
+            <a:endParaRPr lang="en-US" sz="1200" dirty="0"/>
           </a:p>
           <a:p>
             <a:pPr marL="177800" indent="-177800">
@@ -3013,7 +3013,7 @@
               <a:buChar char="•"/>
             </a:pPr>
             <a:r>
-              <a:rPr lang="en-US" sz="1250" dirty="0">
+              <a:rPr lang="en-US" sz="1200" dirty="0">
                 <a:solidFill>
                   <a:srgbClr val="574838"/>
                 </a:solidFill>
@@ -3021,9 +3021,9 @@
                 <a:ea typeface="Trebuchet MS" pitchFamily="34" charset="-122"/>
                 <a:cs typeface="Trebuchet MS" pitchFamily="34" charset="-120"/>
               </a:rPr>
-              <a:t>[ How it wrapped up — what the child said or did at the end ]</a:t>
-            </a:r>
-            <a:endParaRPr lang="en-US" sz="1250" dirty="0"/>
+              <a:t>At the end they turned around and wove back reading the Magic E words — same letters, plus one silent E that changes everything</a:t>
+            </a:r>
+            <a:endParaRPr lang="en-US" sz="1200" dirty="0"/>
           </a:p>
         </p:txBody>
       </p:sp>
@@ -3100,7 +3100,7 @@
                 <a:ea typeface="Trebuchet MS" pitchFamily="34" charset="-122"/>
                 <a:cs typeface="Trebuchet MS" pitchFamily="34" charset="-120"/>
               </a:rPr>
-              <a:t>IN ONE SENTENCE</a:t>
+              <a:t>THE CONCEPT</a:t>
             </a:r>
             <a:endParaRPr lang="en-US" sz="850" dirty="0"/>
           </a:p>
@@ -3117,7 +3117,7 @@
                 <a:ea typeface="Trebuchet MS" pitchFamily="34" charset="-122"/>
                 <a:cs typeface="Trebuchet MS" pitchFamily="34" charset="-120"/>
               </a:rPr>
-              <a:t>[ The heart of this session in your own words ]</a:t>
+              <a:t>Magic E is silent, but it makes the vowel say its name: hop becomes hope.</a:t>
             </a:r>
             <a:endParaRPr lang="en-US" sz="850" dirty="0"/>
           </a:p>
@@ -4036,13 +4036,13 @@
           <a:p>
             <a:pPr marL="177800" indent="-177800">
               <a:spcAft>
-                <a:spcPts val="1000"/>
+                <a:spcPts val="800"/>
               </a:spcAft>
               <a:buSzPct val="100000"/>
               <a:buChar char="•"/>
             </a:pPr>
             <a:r>
-              <a:rPr lang="en-US" sz="1250" dirty="0">
+              <a:rPr lang="en-US" sz="1200" dirty="0">
                 <a:solidFill>
                   <a:srgbClr val="574838"/>
                 </a:solidFill>
@@ -4052,18 +4052,18 @@
               </a:rPr>
               <a:t>[ How the session opened — meeting the horse, settling in ]</a:t>
             </a:r>
-            <a:endParaRPr lang="en-US" sz="1250" dirty="0"/>
+            <a:endParaRPr lang="en-US" sz="1200" dirty="0"/>
           </a:p>
           <a:p>
             <a:pPr marL="177800" indent="-177800">
               <a:spcAft>
-                <a:spcPts val="1000"/>
+                <a:spcPts val="800"/>
               </a:spcAft>
               <a:buSzPct val="100000"/>
               <a:buChar char="•"/>
             </a:pPr>
             <a:r>
-              <a:rPr lang="en-US" sz="1250" dirty="0">
+              <a:rPr lang="en-US" sz="1200" dirty="0">
                 <a:solidFill>
                   <a:srgbClr val="574838"/>
                 </a:solidFill>
@@ -4073,7 +4073,7 @@
               </a:rPr>
               <a:t>[ The main activity — what the child did with the horse and the reading task ]</a:t>
             </a:r>
-            <a:endParaRPr lang="en-US" sz="1250" dirty="0"/>
+            <a:endParaRPr lang="en-US" sz="1200" dirty="0"/>
           </a:p>
           <a:p>
             <a:pPr marL="177800" indent="-177800">
@@ -4081,7 +4081,7 @@
               <a:buChar char="•"/>
             </a:pPr>
             <a:r>
-              <a:rPr lang="en-US" sz="1250" dirty="0">
+              <a:rPr lang="en-US" sz="1200" dirty="0">
                 <a:solidFill>
                   <a:srgbClr val="574838"/>
                 </a:solidFill>
@@ -4091,7 +4091,7 @@
               </a:rPr>
               <a:t>[ How it wrapped up — what the child said or did at the end ]</a:t>
             </a:r>
-            <a:endParaRPr lang="en-US" sz="1250" dirty="0"/>
+            <a:endParaRPr lang="en-US" sz="1200" dirty="0"/>
           </a:p>
         </p:txBody>
       </p:sp>

</xml_diff>

<commit_message>
Fill in Session 1 details: Charlie (6) and Monster, Sunday Aug 23
Co-Authored-By: Claude Fable 5 <noreply@anthropic.com>
Claude-Session: https://claude.ai/code/session_01GSMZNrEY1m6jmPVZHt63bA
</commit_message>
<xml_diff>
--- a/content/presentations/HPR-Class4-Practice-Sessions.pptx
+++ b/content/presentations/HPR-Class4-Practice-Sessions.pptx
@@ -686,7 +686,7 @@
           <a:p>
             <a:r>
               <a:rPr lang="en-US" dirty="0"/>
-              <a:t>Walk the class through Word Racer in about a minute: cones in a weaving pattern, CVC words facing the start (cap, kit, hop), Magic E versions on the back (cape, kite, hope). Down the line reading short vowels, turn around, back up the line reading long ones. Accuracy before speed — with more kids it runs as a relay. The pony sets the pace, which keeps her from rushing the words. Then share what actually happened in your session.</a:t>
+              <a:t>Walk the class through Word Racer in about a minute: cones in a weaving pattern, CVC words facing the start (cap, kit, hop), Magic E versions on the back (cape, kite, hope). Charlie (6) led Monster down the line reading short vowels, turned around, and came back up reading the long ones. Accuracy before speed — with more kids it runs as a relay. Monster sets the pace, which keeps Charlie from rushing the words. Then share what actually happened in your session.</a:t>
             </a:r>
             <a:endParaRPr lang="en-US" dirty="0"/>
           </a:p>
@@ -2299,7 +2299,7 @@
                 <a:ea typeface="Georgia" pitchFamily="34" charset="-122"/>
                 <a:cs typeface="Georgia" pitchFamily="34" charset="-120"/>
               </a:rPr>
-              <a:t>[ Child's first name + age, e.g. “B., age 9” ]</a:t>
+              <a:t>Charlie, age 6</a:t>
             </a:r>
             <a:endParaRPr lang="en-US" sz="900" dirty="0"/>
           </a:p>
@@ -2347,7 +2347,7 @@
                 <a:ea typeface="Georgia" pitchFamily="34" charset="-122"/>
                 <a:cs typeface="Georgia" pitchFamily="34" charset="-120"/>
               </a:rPr>
-              <a:t>[ Which horse or pony joined you ]</a:t>
+              <a:t>Monster</a:t>
             </a:r>
             <a:endParaRPr lang="en-US" sz="900" dirty="0"/>
           </a:p>
@@ -2395,7 +2395,7 @@
                 <a:ea typeface="Georgia" pitchFamily="34" charset="-122"/>
                 <a:cs typeface="Georgia" pitchFamily="34" charset="-120"/>
               </a:rPr>
-              <a:t>[ Date · arena / paddock ]</a:t>
+              <a:t>Sunday, August 23 · the arena</a:t>
             </a:r>
             <a:endParaRPr lang="en-US" sz="900" dirty="0"/>
           </a:p>
@@ -2588,7 +2588,7 @@
                 <a:ea typeface="Georgia" pitchFamily="34" charset="-122"/>
                 <a:cs typeface="Georgia" pitchFamily="34" charset="-120"/>
               </a:rPr>
-              <a:t>[ Child's first name + age, e.g. “B., age 9” ]</a:t>
+              <a:t>[ Child's first name + age ]</a:t>
             </a:r>
             <a:endParaRPr lang="en-US" sz="900" dirty="0"/>
           </a:p>
@@ -3003,7 +3003,7 @@
                 <a:ea typeface="Trebuchet MS" pitchFamily="34" charset="-122"/>
                 <a:cs typeface="Trebuchet MS" pitchFamily="34" charset="-120"/>
               </a:rPr>
-              <a:t>She picked her pony partner, then wove through the cones on the lead line, reading each short-vowel word out loud on the way down</a:t>
+              <a:t>Charlie chose Monster as her pony partner, then wove him through the cones on the lead line, reading each short-vowel word out loud on the way down</a:t>
             </a:r>
             <a:endParaRPr lang="en-US" sz="1200" dirty="0"/>
           </a:p>

</xml_diff>

<commit_message>
Fill in Session 2: Ride to Build a Word with Charlie and Monster
Co-Authored-By: Claude Fable 5 <noreply@anthropic.com>
Claude-Session: https://claude.ai/code/session_01GSMZNrEY1m6jmPVZHt63bA
</commit_message>
<xml_diff>
--- a/content/presentations/HPR-Class4-Practice-Sessions.pptx
+++ b/content/presentations/HPR-Class4-Practice-Sessions.pptx
@@ -862,7 +862,7 @@
           <a:p>
             <a:r>
               <a:rPr lang="en-US" dirty="0"/>
-              <a:t>Walk the class through session 2 in about a minute: the lesson you picked, why it looked fun, and what actually happened. Let the photo do half the talking.</a:t>
+              <a:t>Walk the class through Ride to Build a Word: phonogram discs scattered around the arena on cones, fence posts, and the ground. Charlie carried a beginning-sound card (like R) and led Monster to hunt for the disc that completes a real word — R + -ain = RAIN. Blends work too: T + -rain = TRAIN. The correct disc comes back to the Word Corral, where she physically combines the pieces, then says it, spells it, and uses it in a sentence. The riding/leading turns word-building into a search-and-find with a 300-pound teammate. Then share what actually happened.</a:t>
             </a:r>
             <a:endParaRPr lang="en-US" dirty="0"/>
           </a:p>
@@ -2540,7 +2540,7 @@
                 <a:ea typeface="Georgia" pitchFamily="34" charset="-122"/>
                 <a:cs typeface="Georgia" pitchFamily="34" charset="-120"/>
               </a:rPr>
-              <a:t>[ Lesson name from the HPR curriculum ]</a:t>
+              <a:t>Ride to Build a Word — phonogram blending</a:t>
             </a:r>
             <a:endParaRPr lang="en-US" sz="900" dirty="0"/>
           </a:p>
@@ -2588,7 +2588,7 @@
                 <a:ea typeface="Georgia" pitchFamily="34" charset="-122"/>
                 <a:cs typeface="Georgia" pitchFamily="34" charset="-120"/>
               </a:rPr>
-              <a:t>[ Child's first name + age ]</a:t>
+              <a:t>Charlie, age 6</a:t>
             </a:r>
             <a:endParaRPr lang="en-US" sz="900" dirty="0"/>
           </a:p>
@@ -2636,7 +2636,7 @@
                 <a:ea typeface="Georgia" pitchFamily="34" charset="-122"/>
                 <a:cs typeface="Georgia" pitchFamily="34" charset="-120"/>
               </a:rPr>
-              <a:t>[ Which horse or pony joined you ]</a:t>
+              <a:t>Monster</a:t>
             </a:r>
             <a:endParaRPr lang="en-US" sz="900" dirty="0"/>
           </a:p>
@@ -2684,7 +2684,7 @@
                 <a:ea typeface="Georgia" pitchFamily="34" charset="-122"/>
                 <a:cs typeface="Georgia" pitchFamily="34" charset="-120"/>
               </a:rPr>
-              <a:t>[ Date · arena / paddock ]</a:t>
+              <a:t>Sunday, August 23 · the arena</a:t>
             </a:r>
             <a:endParaRPr lang="en-US" sz="900" dirty="0"/>
           </a:p>
@@ -3999,7 +3999,7 @@
               <a:buNone/>
             </a:pPr>
             <a:r>
-              <a:rPr lang="en-US" sz="2400" dirty="0">
+              <a:rPr lang="en-US" sz="1900" dirty="0">
                 <a:solidFill>
                   <a:srgbClr val="2C2520"/>
                 </a:solidFill>
@@ -4007,9 +4007,9 @@
                 <a:ea typeface="Georgia" pitchFamily="34" charset="-122"/>
                 <a:cs typeface="Georgia" pitchFamily="34" charset="-120"/>
               </a:rPr>
-              <a:t>Session 2: [ Lesson Name ]</a:t>
-            </a:r>
-            <a:endParaRPr lang="en-US" sz="2400" dirty="0"/>
+              <a:t>Session 2: Ride to Build a Word</a:t>
+            </a:r>
+            <a:endParaRPr lang="en-US" sz="1900" dirty="0"/>
           </a:p>
         </p:txBody>
       </p:sp>
@@ -4050,7 +4050,7 @@
                 <a:ea typeface="Trebuchet MS" pitchFamily="34" charset="-122"/>
                 <a:cs typeface="Trebuchet MS" pitchFamily="34" charset="-120"/>
               </a:rPr>
-              <a:t>[ How the session opened — meeting the horse, settling in ]</a:t>
+              <a:t>Phonogram discs placed around the arena — on cones, fence posts, and the ground — with Charlie holding a beginning-sound card like R</a:t>
             </a:r>
             <a:endParaRPr lang="en-US" sz="1200" dirty="0"/>
           </a:p>
@@ -4071,7 +4071,7 @@
                 <a:ea typeface="Trebuchet MS" pitchFamily="34" charset="-122"/>
                 <a:cs typeface="Trebuchet MS" pitchFamily="34" charset="-120"/>
               </a:rPr>
-              <a:t>[ The main activity — what the child did with the horse and the reading task ]</a:t>
+              <a:t>She led Monster around the arena hunting for the disc that completes a real word: R + -ain makes RAIN</a:t>
             </a:r>
             <a:endParaRPr lang="en-US" sz="1200" dirty="0"/>
           </a:p>
@@ -4089,7 +4089,7 @@
                 <a:ea typeface="Trebuchet MS" pitchFamily="34" charset="-122"/>
                 <a:cs typeface="Trebuchet MS" pitchFamily="34" charset="-120"/>
               </a:rPr>
-              <a:t>[ How it wrapped up — what the child said or did at the end ]</a:t>
+              <a:t>Back at the Word Corral she physically joined the pieces, then said the word, spelled it, and used it in a sentence</a:t>
             </a:r>
             <a:endParaRPr lang="en-US" sz="1200" dirty="0"/>
           </a:p>
@@ -4168,7 +4168,7 @@
                 <a:ea typeface="Trebuchet MS" pitchFamily="34" charset="-122"/>
                 <a:cs typeface="Trebuchet MS" pitchFamily="34" charset="-120"/>
               </a:rPr>
-              <a:t>IN ONE SENTENCE</a:t>
+              <a:t>THE CONCEPT</a:t>
             </a:r>
             <a:endParaRPr lang="en-US" sz="850" dirty="0"/>
           </a:p>
@@ -4185,7 +4185,7 @@
                 <a:ea typeface="Trebuchet MS" pitchFamily="34" charset="-122"/>
                 <a:cs typeface="Trebuchet MS" pitchFamily="34" charset="-120"/>
               </a:rPr>
-              <a:t>[ The heart of this session in your own words ]</a:t>
+              <a:t>One beginning sound plus the right phonogram builds a real word: R + ain = rain.</a:t>
             </a:r>
             <a:endParaRPr lang="en-US" sz="850" dirty="0"/>
           </a:p>

</xml_diff>

<commit_message>
Fill in the Class 4 deck from the Aug 27 practice sessions
Both sessions ran Thursday, August 27 at the ranch with Charlie (6)
and Charlie the Fjord. Session write ups, all five reflection prompts,
the metaphor, GLOW & GROW, and the closing plan are now filled from
the session videos and transcripts. Session photos swapped for real
action shots (Magic E wand frame, W mailbox shot). Session 2 renamed
Special Delivery to match the mailbox game actually played. Checklist
updated: session journals and the deck upload are all that remain.

Co-Authored-By: Claude Fable 5 <noreply@anthropic.com>
</commit_message>
<xml_diff>
--- a/content/presentations/HPR-Class4-Practice-Sessions.pptx
+++ b/content/presentations/HPR-Class4-Practice-Sessions.pptx
@@ -686,7 +686,7 @@
           <a:p>
             <a:r>
               <a:rPr lang="en-US" dirty="0"/>
-              <a:t>Walk the class through Word Racer in about a minute: cones in a weaving pattern, CVC words facing the start (cap, kit, hop), Magic E versions on the back (cape, kite, hope). Charlie (6) led Monster down the line reading short vowels, turned around, and came back up reading the long ones. Accuracy before speed — with more kids it runs as a relay. Monster sets the pace, which keeps Charlie from rushing the words. Then share what actually happened in your session.</a:t>
+              <a:t>Walk the class through Word Racer in about a minute: word cards taped to the cones, Magic E wand in hand. Charlie the Fjord walked the line and stopped to pick each card. Charlie read the short vowel word, tapped it with the wand, and read the new word: tap to tape, kit to kite. He set the pace, which kept her from rushing. About 45 seconds here, then the reflections carry the weight.</a:t>
             </a:r>
             <a:endParaRPr lang="en-US" dirty="0"/>
           </a:p>
@@ -862,7 +862,7 @@
           <a:p>
             <a:r>
               <a:rPr lang="en-US" dirty="0"/>
-              <a:t>Walk the class through Ride to Build a Word: phonogram discs scattered around the arena on cones, fence posts, and the ground. Charlie carried a beginning-sound card (like R) and led Monster to hunt for the disc that completes a real word — R + -ain = RAIN. Blends work too: T + -rain = TRAIN. The correct disc comes back to the Word Corral, where she physically combines the pieces, then says it, spells it, and uses it in a sentence. The riding/leading turns word-building into a search-and-find with a 300-pound teammate. Then share what actually happened.</a:t>
+              <a:t>Walk the class through Special Delivery in about a minute: a toy mailbox with W on the front, phonogram discs beside it. Charlie tested each disc against the W, sounded out the pair, and ruled real or silly. Real words got mailed: wash, way, wow. Sillies got tossed, and wame drew the biggest laugh. One disc sat upside down until she flipped it and found wow. She kept count to the end.</a:t>
             </a:r>
             <a:endParaRPr lang="en-US" dirty="0"/>
           </a:p>
@@ -2251,7 +2251,7 @@
                 <a:ea typeface="Georgia" pitchFamily="34" charset="-122"/>
                 <a:cs typeface="Georgia" pitchFamily="34" charset="-120"/>
               </a:rPr>
-              <a:t>Word Racer — CVC words &amp; Magic E</a:t>
+              <a:t>Word Racer: CVC words &amp; Magic E</a:t>
             </a:r>
             <a:endParaRPr lang="en-US" sz="900" dirty="0"/>
           </a:p>
@@ -2347,7 +2347,7 @@
                 <a:ea typeface="Georgia" pitchFamily="34" charset="-122"/>
                 <a:cs typeface="Georgia" pitchFamily="34" charset="-120"/>
               </a:rPr>
-              <a:t>Monster</a:t>
+              <a:t>Charlie the Fjord</a:t>
             </a:r>
             <a:endParaRPr lang="en-US" sz="900" dirty="0"/>
           </a:p>
@@ -2395,7 +2395,7 @@
                 <a:ea typeface="Georgia" pitchFamily="34" charset="-122"/>
                 <a:cs typeface="Georgia" pitchFamily="34" charset="-120"/>
               </a:rPr>
-              <a:t>Sunday, August 23 · the arena</a:t>
+              <a:t>Thursday, August 27 · the ranch</a:t>
             </a:r>
             <a:endParaRPr lang="en-US" sz="900" dirty="0"/>
           </a:p>
@@ -2540,7 +2540,7 @@
                 <a:ea typeface="Georgia" pitchFamily="34" charset="-122"/>
                 <a:cs typeface="Georgia" pitchFamily="34" charset="-120"/>
               </a:rPr>
-              <a:t>Ride to Build a Word — phonogram blending</a:t>
+              <a:t>Special Delivery: word family mailbox</a:t>
             </a:r>
             <a:endParaRPr lang="en-US" sz="900" dirty="0"/>
           </a:p>
@@ -2636,7 +2636,7 @@
                 <a:ea typeface="Georgia" pitchFamily="34" charset="-122"/>
                 <a:cs typeface="Georgia" pitchFamily="34" charset="-120"/>
               </a:rPr>
-              <a:t>Monster</a:t>
+              <a:t>Charlie the Fjord</a:t>
             </a:r>
             <a:endParaRPr lang="en-US" sz="900" dirty="0"/>
           </a:p>
@@ -2684,7 +2684,7 @@
                 <a:ea typeface="Georgia" pitchFamily="34" charset="-122"/>
                 <a:cs typeface="Georgia" pitchFamily="34" charset="-120"/>
               </a:rPr>
-              <a:t>Sunday, August 23 · the arena</a:t>
+              <a:t>Thursday, August 27 · the trailer</a:t>
             </a:r>
             <a:endParaRPr lang="en-US" sz="900" dirty="0"/>
           </a:p>
@@ -2982,7 +2982,7 @@
                 <a:ea typeface="Trebuchet MS" pitchFamily="34" charset="-122"/>
                 <a:cs typeface="Trebuchet MS" pitchFamily="34" charset="-120"/>
               </a:rPr>
-              <a:t>Cones set in a weaving pattern, a word card on each side — a CVC word facing the start (cap, kit, hop), its Magic E partner on the back (cape, kite, hope)</a:t>
+              <a:t>A word card taped to every cone. Charlie the Fjord walked the line and stopped where he chose. Whatever cone he picked, that was her word.</a:t>
             </a:r>
             <a:endParaRPr lang="en-US" sz="1200" dirty="0"/>
           </a:p>
@@ -3003,7 +3003,7 @@
                 <a:ea typeface="Trebuchet MS" pitchFamily="34" charset="-122"/>
                 <a:cs typeface="Trebuchet MS" pitchFamily="34" charset="-120"/>
               </a:rPr>
-              <a:t>Charlie chose Monster as her pony partner, then wove him through the cones on the lead line, reading each short-vowel word out loud on the way down</a:t>
+              <a:t>Charlie read the short word out loud, then tapped the card with her Magic E wand. Pew. Tap turned into tape, kit turned into kite.</a:t>
             </a:r>
             <a:endParaRPr lang="en-US" sz="1200" dirty="0"/>
           </a:p>
@@ -3021,7 +3021,7 @@
                 <a:ea typeface="Trebuchet MS" pitchFamily="34" charset="-122"/>
                 <a:cs typeface="Trebuchet MS" pitchFamily="34" charset="-120"/>
               </a:rPr>
-              <a:t>At the end they turned around and wove back reading the Magic E words — same letters, plus one silent E that changes everything</a:t>
+              <a:t>She started the session not knowing what the silent E does. Two cards later she was telling me: it goes quiet and the vowel says its name.</a:t>
             </a:r>
             <a:endParaRPr lang="en-US" sz="1200" dirty="0"/>
           </a:p>
@@ -3117,7 +3117,7 @@
                 <a:ea typeface="Trebuchet MS" pitchFamily="34" charset="-122"/>
                 <a:cs typeface="Trebuchet MS" pitchFamily="34" charset="-120"/>
               </a:rPr>
-              <a:t>Magic E is silent, but it makes the vowel say its name: hop becomes hope.</a:t>
+              <a:t>Magic E is silent, but it makes the vowel say its name: tap becomes tape.</a:t>
             </a:r>
             <a:endParaRPr lang="en-US" sz="850" dirty="0"/>
           </a:p>
@@ -3532,7 +3532,7 @@
                 <a:ea typeface="Trebuchet MS" pitchFamily="34" charset="-122"/>
                 <a:cs typeface="Trebuchet MS" pitchFamily="34" charset="-120"/>
               </a:rPr>
-              <a:t>[ One moment that stood out — be specific: what the child said or did, what shifted ]</a:t>
+              <a:t>I asked what the Magic E does. She said no. Two cards later she was telling me: the E goes silent and the vowel says its name. Kit became kite, and she read it like she owned it.</a:t>
             </a:r>
             <a:endParaRPr lang="en-US" sz="850" dirty="0"/>
           </a:p>
@@ -3642,7 +3642,7 @@
                 <a:ea typeface="Trebuchet MS" pitchFamily="34" charset="-122"/>
                 <a:cs typeface="Trebuchet MS" pitchFamily="34" charset="-120"/>
               </a:rPr>
-              <a:t>[ What this session taught you as a facilitator ]</a:t>
+              <a:t>Let the pony deal the cards. When Charlie the Fjord stopped and chose the next word, the drill became his game and she wanted a turn in it. My job was one question at a time, then wait.</a:t>
             </a:r>
             <a:endParaRPr lang="en-US" sz="850" dirty="0"/>
           </a:p>
@@ -3752,7 +3752,7 @@
                 <a:ea typeface="Trebuchet MS" pitchFamily="34" charset="-122"/>
                 <a:cs typeface="Trebuchet MS" pitchFamily="34" charset="-120"/>
               </a:rPr>
-              <a:t>[ A moment the horse held space, gave feedback, or encouraged the reader ]</a:t>
+              <a:t>He stood stone quiet while she worked out K, I, T with his lead in one hand and the wand in the other. I told her you can hold it, he will stay. He stayed. His stillness bought her the time to finish the word.</a:t>
             </a:r>
             <a:endParaRPr lang="en-US" sz="850" dirty="0"/>
           </a:p>
@@ -4007,7 +4007,7 @@
                 <a:ea typeface="Georgia" pitchFamily="34" charset="-122"/>
                 <a:cs typeface="Georgia" pitchFamily="34" charset="-120"/>
               </a:rPr>
-              <a:t>Session 2: Ride to Build a Word</a:t>
+              <a:t>Session 2: Special Delivery</a:t>
             </a:r>
             <a:endParaRPr lang="en-US" sz="1900" dirty="0"/>
           </a:p>
@@ -4050,7 +4050,7 @@
                 <a:ea typeface="Trebuchet MS" pitchFamily="34" charset="-122"/>
                 <a:cs typeface="Trebuchet MS" pitchFamily="34" charset="-120"/>
               </a:rPr>
-              <a:t>Phonogram discs placed around the arena — on cones, fence posts, and the ground — with Charlie holding a beginning-sound card like R</a:t>
+              <a:t>A toy mailbox with a big W on the front, set on the trailer fender, with a stack of phonogram discs beside it: ash, ay, ame, oke, ow.</a:t>
             </a:r>
             <a:endParaRPr lang="en-US" sz="1200" dirty="0"/>
           </a:p>
@@ -4071,7 +4071,7 @@
                 <a:ea typeface="Trebuchet MS" pitchFamily="34" charset="-122"/>
                 <a:cs typeface="Trebuchet MS" pitchFamily="34" charset="-120"/>
               </a:rPr>
-              <a:t>She led Monster around the arena hunting for the disc that completes a real word: R + -ain makes RAIN</a:t>
+              <a:t>Charlie held each disc up to the W and sounded out the pair. Real words like wash and way got mailed. Sillies like wame got tossed, with giggles.</a:t>
             </a:r>
             <a:endParaRPr lang="en-US" sz="1200" dirty="0"/>
           </a:p>
@@ -4089,7 +4089,7 @@
                 <a:ea typeface="Trebuchet MS" pitchFamily="34" charset="-122"/>
                 <a:cs typeface="Trebuchet MS" pitchFamily="34" charset="-120"/>
               </a:rPr>
-              <a:t>Back at the Word Corral she physically joined the pieces, then said the word, spelled it, and used it in a sentence</a:t>
+              <a:t>One disc read as nonsense until she flipped it right side up and found wow. She kept count of every real word she dropped in the box.</a:t>
             </a:r>
             <a:endParaRPr lang="en-US" sz="1200" dirty="0"/>
           </a:p>
@@ -4185,7 +4185,7 @@
                 <a:ea typeface="Trebuchet MS" pitchFamily="34" charset="-122"/>
                 <a:cs typeface="Trebuchet MS" pitchFamily="34" charset="-120"/>
               </a:rPr>
-              <a:t>One beginning sound plus the right phonogram builds a real word: R + ain = rain.</a:t>
+              <a:t>One beginning sound plus the right chunk builds a real word: W + ash = wash.</a:t>
             </a:r>
             <a:endParaRPr lang="en-US" sz="850" dirty="0"/>
           </a:p>
@@ -4600,7 +4600,7 @@
                 <a:ea typeface="Trebuchet MS" pitchFamily="34" charset="-122"/>
                 <a:cs typeface="Trebuchet MS" pitchFamily="34" charset="-120"/>
               </a:rPr>
-              <a:t>[ One moment that stood out — be specific: what the child said or did, what shifted ]</a:t>
+              <a:t>The upside down disc. She read woo, frowned, got one hint, flipped it, and pulled out wow. Then she said it four more times, because winning a word feels that good.</a:t>
             </a:r>
             <a:endParaRPr lang="en-US" sz="850" dirty="0"/>
           </a:p>
@@ -4710,7 +4710,7 @@
                 <a:ea typeface="Trebuchet MS" pitchFamily="34" charset="-122"/>
                 <a:cs typeface="Trebuchet MS" pitchFamily="34" charset="-120"/>
               </a:rPr>
-              <a:t>[ What this session taught you as a facilitator ]</a:t>
+              <a:t>The no answers teach as much as the yes answers. Sounding out wame and ruling it not a word works the same muscle as reading wash. Keeping count turned judging into a game instead of a test.</a:t>
             </a:r>
             <a:endParaRPr lang="en-US" sz="850" dirty="0"/>
           </a:p>
@@ -4820,7 +4820,7 @@
                 <a:ea typeface="Trebuchet MS" pitchFamily="34" charset="-122"/>
                 <a:cs typeface="Trebuchet MS" pitchFamily="34" charset="-120"/>
               </a:rPr>
-              <a:t>[ A moment the horse held space, gave feedback, or encouraged the reader ]</a:t>
+              <a:t>His work came first. The session with Charlie the Fjord built the calm she carried straight to the mailbox, halters at her feet and the trailer fender for a desk.</a:t>
             </a:r>
             <a:endParaRPr lang="en-US" sz="850" dirty="0"/>
           </a:p>
@@ -5110,7 +5110,7 @@
                 <a:ea typeface="Georgia" pitchFamily="34" charset="-122"/>
                 <a:cs typeface="Georgia" pitchFamily="34" charset="-120"/>
               </a:rPr>
-              <a:t>[ Your metaphor — e.g. “the way she kept a loose lead rope was the way she finally stopped white-knuckling the words” ]</a:t>
+              <a:t>She read the disc upside down and got nonsense. She turned it, and it said wow.</a:t>
             </a:r>
             <a:endParaRPr lang="en-US" sz="2000" dirty="0"/>
           </a:p>
@@ -5172,7 +5172,7 @@
                 <a:ea typeface="Trebuchet MS" pitchFamily="34" charset="-122"/>
                 <a:cs typeface="Trebuchet MS" pitchFamily="34" charset="-120"/>
               </a:rPr>
-              <a:t>[ One or two sentences on why this metaphor fits — what it showed you about the child, the horse, or reading itself ]</a:t>
+              <a:t>That is a struggling reader in one disc. The letters were never wrong. She held the word the wrong way up, and nobody grabbed it out of her hands. My job, and the pony's, is to stand quiet and give her room to turn it.</a:t>
             </a:r>
             <a:endParaRPr lang="en-US" sz="1200" dirty="0"/>
           </a:p>
@@ -5605,7 +5605,7 @@
                 <a:ea typeface="Trebuchet MS" pitchFamily="34" charset="-122"/>
                 <a:cs typeface="Trebuchet MS" pitchFamily="34" charset="-120"/>
               </a:rPr>
-              <a:t>[ What you did well as a facilitator ]</a:t>
+              <a:t>Asked one question at a time, then waited. The quiet did the teaching.</a:t>
             </a:r>
             <a:endParaRPr lang="en-US" sz="1050" dirty="0"/>
           </a:p>
@@ -5669,7 +5669,7 @@
                 <a:ea typeface="Trebuchet MS" pitchFamily="34" charset="-122"/>
                 <a:cs typeface="Trebuchet MS" pitchFamily="34" charset="-120"/>
               </a:rPr>
-              <a:t>[ What you'll do differently next time ]</a:t>
+              <a:t>I handed her the Magic E answer instead of letting her guess first. Next time I ask twice before I tell.</a:t>
             </a:r>
             <a:endParaRPr lang="en-US" sz="1050" dirty="0"/>
           </a:p>
@@ -5792,7 +5792,7 @@
                 <a:ea typeface="Trebuchet MS" pitchFamily="34" charset="-122"/>
                 <a:cs typeface="Trebuchet MS" pitchFamily="34" charset="-120"/>
               </a:rPr>
-              <a:t>[ Where the child shined ]</a:t>
+              <a:t>Spelled every word out loud before saying it, and called real or silly on her own by the end.</a:t>
             </a:r>
             <a:endParaRPr lang="en-US" sz="1050" dirty="0"/>
           </a:p>
@@ -5856,7 +5856,7 @@
                 <a:ea typeface="Trebuchet MS" pitchFamily="34" charset="-122"/>
                 <a:cs typeface="Trebuchet MS" pitchFamily="34" charset="-120"/>
               </a:rPr>
-              <a:t>[ Where the child stretched or grew ]</a:t>
+              <a:t>Short vowel sounds still wobble, ah versus A. The wand gave her the why. Now she needs the reps.</a:t>
             </a:r>
             <a:endParaRPr lang="en-US" sz="1050" dirty="0"/>
           </a:p>
@@ -5979,7 +5979,7 @@
                 <a:ea typeface="Trebuchet MS" pitchFamily="34" charset="-122"/>
                 <a:cs typeface="Trebuchet MS" pitchFamily="34" charset="-120"/>
               </a:rPr>
-              <a:t>[ What the horse brought to the session ]</a:t>
+              <a:t>He picked word cards like he was dealt into the game, then stood like a stone while she read.</a:t>
             </a:r>
             <a:endParaRPr lang="en-US" sz="1050" dirty="0"/>
           </a:p>
@@ -6043,7 +6043,7 @@
                 <a:ea typeface="Trebuchet MS" pitchFamily="34" charset="-122"/>
                 <a:cs typeface="Trebuchet MS" pitchFamily="34" charset="-120"/>
               </a:rPr>
-              <a:t>[ What the horse taught — or is still learning ]</a:t>
+              <a:t>Walking a cone line past loose hay without a snack stop is still a lesson in progress.</a:t>
             </a:r>
             <a:endParaRPr lang="en-US" sz="1050" dirty="0"/>
           </a:p>
@@ -6357,7 +6357,7 @@
                 <a:ea typeface="Georgia" pitchFamily="34" charset="-122"/>
                 <a:cs typeface="Georgia" pitchFamily="34" charset="-120"/>
               </a:rPr>
-              <a:t>[ One or two lines on your plan — e.g. bringing Horse Powered Reading into Tribal Cowboy's school and community programs, and which readers or schools you want to reach first ]</a:t>
+              <a:t>Horse Powered Reading folds into Tribal Cowboy's Pony Express Program: reading sessions at the ranch and school visits across Kootenai and Bonner counties, starting with the kids reading below grade level.</a:t>
             </a:r>
             <a:endParaRPr lang="en-US" sz="1300" dirty="0"/>
           </a:p>

</xml_diff>

<commit_message>
Stacie's voice pass: Aug 21 date, 3D printed wand, Pony Express Mailbox scoring
Sessions dated Friday, August 21. Slide 3 credits the 3D printed
Magic E wand. Session 2 renamed Pony Express Mailbox: a letter written
on the mailbox, 3D printed phonogram discs, and a point for every real
word she got in. Reflection copy tightened to sound like Stacie.

Co-Authored-By: Claude Fable 5 <noreply@anthropic.com>
</commit_message>
<xml_diff>
--- a/content/presentations/HPR-Class4-Practice-Sessions.pptx
+++ b/content/presentations/HPR-Class4-Practice-Sessions.pptx
@@ -686,7 +686,7 @@
           <a:p>
             <a:r>
               <a:rPr lang="en-US" dirty="0"/>
-              <a:t>Walk the class through Word Racer in about a minute: word cards taped to the cones, Magic E wand in hand. Charlie the Fjord walked the line and stopped to pick each card. Charlie read the short vowel word, tapped it with the wand, and read the new word: tap to tape, kit to kite. He set the pace, which kept her from rushing. About 45 seconds here, then the reflections carry the weight.</a:t>
+              <a:t>Walk the class through Word Racer in about a minute: word cards taped to the cones and the Magic E wand I 3D printed. Charlie the Fjord walked the line and stopped to pick each card. Charlie read the short vowel word, tapped it with the wand, and read the new word: tap to tape, kit to kite. He set the pace, which kept her from rushing. About 45 seconds here, then the reflections carry the weight.</a:t>
             </a:r>
             <a:endParaRPr lang="en-US" dirty="0"/>
           </a:p>
@@ -862,7 +862,7 @@
           <a:p>
             <a:r>
               <a:rPr lang="en-US" dirty="0"/>
-              <a:t>Walk the class through Special Delivery in about a minute: a toy mailbox with W on the front, phonogram discs beside it. Charlie tested each disc against the W, sounded out the pair, and ruled real or silly. Real words got mailed: wash, way, wow. Sillies got tossed, and wame drew the biggest laugh. One disc sat upside down until she flipped it and found wow. She kept count to the end.</a:t>
+              <a:t>Walk the class through the Pony Express Mailbox in about a minute: I wrote a W on the mailbox and 3D printed the phonogram discs. Charlie tested each disc against the letter, sounded out the pair, and called it real or silly. Real words went in the mailbox for a point each: wash, way, wow. Sillies got tossed, and wame drew the biggest laugh. One disc sat upside down until she flipped it and found wow. Points counted to the end.</a:t>
             </a:r>
             <a:endParaRPr lang="en-US" dirty="0"/>
           </a:p>
@@ -2395,7 +2395,7 @@
                 <a:ea typeface="Georgia" pitchFamily="34" charset="-122"/>
                 <a:cs typeface="Georgia" pitchFamily="34" charset="-120"/>
               </a:rPr>
-              <a:t>Thursday, August 27 · the ranch</a:t>
+              <a:t>Friday, August 21 · the ranch</a:t>
             </a:r>
             <a:endParaRPr lang="en-US" sz="900" dirty="0"/>
           </a:p>
@@ -2540,7 +2540,7 @@
                 <a:ea typeface="Georgia" pitchFamily="34" charset="-122"/>
                 <a:cs typeface="Georgia" pitchFamily="34" charset="-120"/>
               </a:rPr>
-              <a:t>Special Delivery: word family mailbox</a:t>
+              <a:t>Pony Express Mailbox: letter + 3D discs</a:t>
             </a:r>
             <a:endParaRPr lang="en-US" sz="900" dirty="0"/>
           </a:p>
@@ -2684,7 +2684,7 @@
                 <a:ea typeface="Georgia" pitchFamily="34" charset="-122"/>
                 <a:cs typeface="Georgia" pitchFamily="34" charset="-120"/>
               </a:rPr>
-              <a:t>Thursday, August 27 · the trailer</a:t>
+              <a:t>Friday, August 21 · the trailer</a:t>
             </a:r>
             <a:endParaRPr lang="en-US" sz="900" dirty="0"/>
           </a:p>
@@ -2982,7 +2982,7 @@
                 <a:ea typeface="Trebuchet MS" pitchFamily="34" charset="-122"/>
                 <a:cs typeface="Trebuchet MS" pitchFamily="34" charset="-120"/>
               </a:rPr>
-              <a:t>A word card taped to every cone. Charlie the Fjord walked the line and stopped where he chose. Whatever cone he picked, that was her word.</a:t>
+              <a:t>Word cards taped to the cones. Charlie the Fjord walked the line and stopped where he wanted. Whatever cone he picked, that was her word.</a:t>
             </a:r>
             <a:endParaRPr lang="en-US" sz="1200" dirty="0"/>
           </a:p>
@@ -3003,7 +3003,7 @@
                 <a:ea typeface="Trebuchet MS" pitchFamily="34" charset="-122"/>
                 <a:cs typeface="Trebuchet MS" pitchFamily="34" charset="-120"/>
               </a:rPr>
-              <a:t>Charlie read the short word out loud, then tapped the card with her Magic E wand. Pew. Tap turned into tape, kit turned into kite.</a:t>
+              <a:t>Charlie read the short word out loud, then tapped the card with the Magic E wand I 3D printed. Pew. Tap turned into tape, kit turned into kite.</a:t>
             </a:r>
             <a:endParaRPr lang="en-US" sz="1200" dirty="0"/>
           </a:p>
@@ -3021,7 +3021,7 @@
                 <a:ea typeface="Trebuchet MS" pitchFamily="34" charset="-122"/>
                 <a:cs typeface="Trebuchet MS" pitchFamily="34" charset="-120"/>
               </a:rPr>
-              <a:t>She started the session not knowing what the silent E does. Two cards later she was telling me: it goes quiet and the vowel says its name.</a:t>
+              <a:t>She started with no clue what the silent E does. Two cards later she was telling me: it goes quiet and the vowel says its name.</a:t>
             </a:r>
             <a:endParaRPr lang="en-US" sz="1200" dirty="0"/>
           </a:p>
@@ -3532,7 +3532,7 @@
                 <a:ea typeface="Trebuchet MS" pitchFamily="34" charset="-122"/>
                 <a:cs typeface="Trebuchet MS" pitchFamily="34" charset="-120"/>
               </a:rPr>
-              <a:t>I asked what the Magic E does. She said no. Two cards later she was telling me: the E goes silent and the vowel says its name. Kit became kite, and she read it like she owned it.</a:t>
+              <a:t>I asked what the Magic E does and got a flat no. Two cards later she was telling me: the E goes silent and the vowel says its name. Kit became kite, and she read it like she owned it.</a:t>
             </a:r>
             <a:endParaRPr lang="en-US" sz="850" dirty="0"/>
           </a:p>
@@ -3752,7 +3752,7 @@
                 <a:ea typeface="Trebuchet MS" pitchFamily="34" charset="-122"/>
                 <a:cs typeface="Trebuchet MS" pitchFamily="34" charset="-120"/>
               </a:rPr>
-              <a:t>He stood stone quiet while she worked out K, I, T with his lead in one hand and the wand in the other. I told her you can hold it, he will stay. He stayed. His stillness bought her the time to finish the word.</a:t>
+              <a:t>He stood dead quiet while she worked out K, I, T with his lead in one hand and the wand in the other. I told her you can hold it, he will stay. He did. That gave her the time to finish the word.</a:t>
             </a:r>
             <a:endParaRPr lang="en-US" sz="850" dirty="0"/>
           </a:p>
@@ -4007,7 +4007,7 @@
                 <a:ea typeface="Georgia" pitchFamily="34" charset="-122"/>
                 <a:cs typeface="Georgia" pitchFamily="34" charset="-120"/>
               </a:rPr>
-              <a:t>Session 2: Special Delivery</a:t>
+              <a:t>Session 2: Pony Express Mailbox</a:t>
             </a:r>
             <a:endParaRPr lang="en-US" sz="1900" dirty="0"/>
           </a:p>
@@ -4050,7 +4050,7 @@
                 <a:ea typeface="Trebuchet MS" pitchFamily="34" charset="-122"/>
                 <a:cs typeface="Trebuchet MS" pitchFamily="34" charset="-120"/>
               </a:rPr>
-              <a:t>A toy mailbox with a big W on the front, set on the trailer fender, with a stack of phonogram discs beside it: ash, ay, ame, oke, ow.</a:t>
+              <a:t>I wrote a big W on the mailbox and set it on the trailer fender with a stack of 3D printed phonogram discs: ash, ay, ame, oke, ow.</a:t>
             </a:r>
             <a:endParaRPr lang="en-US" sz="1200" dirty="0"/>
           </a:p>
@@ -4071,7 +4071,7 @@
                 <a:ea typeface="Trebuchet MS" pitchFamily="34" charset="-122"/>
                 <a:cs typeface="Trebuchet MS" pitchFamily="34" charset="-120"/>
               </a:rPr>
-              <a:t>Charlie held each disc up to the W and sounded out the pair. Real words like wash and way got mailed. Sillies like wame got tossed, with giggles.</a:t>
+              <a:t>Charlie held each disc up to the letter and sounded out the pair. Real words like wash and way went in the mailbox. Sillies like wame got tossed, with giggles.</a:t>
             </a:r>
             <a:endParaRPr lang="en-US" sz="1200" dirty="0"/>
           </a:p>
@@ -4089,7 +4089,7 @@
                 <a:ea typeface="Trebuchet MS" pitchFamily="34" charset="-122"/>
                 <a:cs typeface="Trebuchet MS" pitchFamily="34" charset="-120"/>
               </a:rPr>
-              <a:t>One disc read as nonsense until she flipped it right side up and found wow. She kept count of every real word she dropped in the box.</a:t>
+              <a:t>Every disc she got in the mailbox earned a point. One read as nonsense until she flipped it and found wow. She counted her points to the end.</a:t>
             </a:r>
             <a:endParaRPr lang="en-US" sz="1200" dirty="0"/>
           </a:p>
@@ -4185,7 +4185,7 @@
                 <a:ea typeface="Trebuchet MS" pitchFamily="34" charset="-122"/>
                 <a:cs typeface="Trebuchet MS" pitchFamily="34" charset="-120"/>
               </a:rPr>
-              <a:t>One beginning sound plus the right chunk builds a real word: W + ash = wash.</a:t>
+              <a:t>One letter plus the right disc builds a real word: W + ash = wash.</a:t>
             </a:r>
             <a:endParaRPr lang="en-US" sz="850" dirty="0"/>
           </a:p>
@@ -4600,7 +4600,7 @@
                 <a:ea typeface="Trebuchet MS" pitchFamily="34" charset="-122"/>
                 <a:cs typeface="Trebuchet MS" pitchFamily="34" charset="-120"/>
               </a:rPr>
-              <a:t>The upside down disc. She read woo, frowned, got one hint, flipped it, and pulled out wow. Then she said it four more times, because winning a word feels that good.</a:t>
+              <a:t>The upside down disc. She read woo, frowned, got one hint, flipped it, and got wow. Then said it four more times because she earned it.</a:t>
             </a:r>
             <a:endParaRPr lang="en-US" sz="850" dirty="0"/>
           </a:p>
@@ -4710,7 +4710,7 @@
                 <a:ea typeface="Trebuchet MS" pitchFamily="34" charset="-122"/>
                 <a:cs typeface="Trebuchet MS" pitchFamily="34" charset="-120"/>
               </a:rPr>
-              <a:t>The no answers teach as much as the yes answers. Sounding out wame and ruling it not a word works the same muscle as reading wash. Keeping count turned judging into a game instead of a test.</a:t>
+              <a:t>The no answers teach as much as the yes answers. Sounding out wame and ruling it not a word works the same muscle as reading wash. Points turned real versus silly into a game instead of a test.</a:t>
             </a:r>
             <a:endParaRPr lang="en-US" sz="850" dirty="0"/>
           </a:p>
@@ -5605,7 +5605,7 @@
                 <a:ea typeface="Trebuchet MS" pitchFamily="34" charset="-122"/>
                 <a:cs typeface="Trebuchet MS" pitchFamily="34" charset="-120"/>
               </a:rPr>
-              <a:t>Asked one question at a time, then waited. The quiet did the teaching.</a:t>
+              <a:t>One question at a time, then wait. The quiet did more teaching than I did.</a:t>
             </a:r>
             <a:endParaRPr lang="en-US" sz="1050" dirty="0"/>
           </a:p>

</xml_diff>

<commit_message>
Slide 3: 2x2 photo grid of four session 1 video frames
Pony picking his cone, the 3D printed Magic E wand at the card,
Charlie walking the line with wand and lead, and the smile after
kit became kite. All inside the existing gold frame.

Co-Authored-By: Claude Fable 5 <noreply@anthropic.com>
</commit_message>
<xml_diff>
--- a/content/presentations/HPR-Class4-Practice-Sessions.pptx
+++ b/content/presentations/HPR-Class4-Practice-Sessions.pptx
@@ -3125,7 +3125,7 @@
       </p:sp>
       <p:pic>
         <p:nvPicPr>
-          <p:cNvPr id="10" name="Image 1" descr="/tmp/claude-0/-home-user-tribal-cowboy-webhook/9ba9e801-9603-5165-907c-67d024c96ac6/scratchpad/session1-photo-small.jpg">    </p:cNvPr>
+          <p:cNvPr id="30" name="Session1 Photo 1" descr="session photo"/>
           <p:cNvPicPr>
             <a:picLocks noChangeAspect="1"/>
           </p:cNvPicPr>
@@ -3133,13 +3133,86 @@
         </p:nvPicPr>
         <p:blipFill>
           <a:blip r:embed="rId2"/>
-          <a:srcRect l="0" r="0" t="0" b="0"/>
-          <a:stretch/>
+          <a:stretch>
+            <a:fillRect/>
+          </a:stretch>
         </p:blipFill>
         <p:spPr>
           <a:xfrm>
             <a:off x="5486400" y="960120"/>
-            <a:ext cx="3108960" cy="3566160"/>
+            <a:ext cx="1527048" cy="1755648"/>
+          </a:xfrm>
+          <a:prstGeom prst="rect">
+            <a:avLst/>
+          </a:prstGeom>
+        </p:spPr>
+      </p:pic>
+      <p:pic>
+        <p:nvPicPr>
+          <p:cNvPr id="31" name="Session1 Photo 2" descr="session photo"/>
+          <p:cNvPicPr>
+            <a:picLocks noChangeAspect="1"/>
+          </p:cNvPicPr>
+          <p:nvPr/>
+        </p:nvPicPr>
+        <p:blipFill>
+          <a:blip r:embed="rId5"/>
+          <a:stretch>
+            <a:fillRect/>
+          </a:stretch>
+        </p:blipFill>
+        <p:spPr>
+          <a:xfrm>
+            <a:off x="7068312" y="960120"/>
+            <a:ext cx="1527048" cy="1755648"/>
+          </a:xfrm>
+          <a:prstGeom prst="rect">
+            <a:avLst/>
+          </a:prstGeom>
+        </p:spPr>
+      </p:pic>
+      <p:pic>
+        <p:nvPicPr>
+          <p:cNvPr id="32" name="Session1 Photo 3" descr="session photo"/>
+          <p:cNvPicPr>
+            <a:picLocks noChangeAspect="1"/>
+          </p:cNvPicPr>
+          <p:nvPr/>
+        </p:nvPicPr>
+        <p:blipFill>
+          <a:blip r:embed="rId6"/>
+          <a:stretch>
+            <a:fillRect/>
+          </a:stretch>
+        </p:blipFill>
+        <p:spPr>
+          <a:xfrm>
+            <a:off x="5486400" y="2770632"/>
+            <a:ext cx="1527048" cy="1755648"/>
+          </a:xfrm>
+          <a:prstGeom prst="rect">
+            <a:avLst/>
+          </a:prstGeom>
+        </p:spPr>
+      </p:pic>
+      <p:pic>
+        <p:nvPicPr>
+          <p:cNvPr id="33" name="Session1 Photo 4" descr="session photo"/>
+          <p:cNvPicPr>
+            <a:picLocks noChangeAspect="1"/>
+          </p:cNvPicPr>
+          <p:nvPr/>
+        </p:nvPicPr>
+        <p:blipFill>
+          <a:blip r:embed="rId7"/>
+          <a:stretch>
+            <a:fillRect/>
+          </a:stretch>
+        </p:blipFill>
+        <p:spPr>
+          <a:xfrm>
+            <a:off x="7068312" y="2770632"/>
+            <a:ext cx="1527048" cy="1755648"/>
           </a:xfrm>
           <a:prstGeom prst="rect">
             <a:avLst/>

</xml_diff>

<commit_message>
Slide 3: six full uncropped video frames, true 9:16, no stretch or zoom
Co-Authored-By: Claude Fable 5 <noreply@anthropic.com>
</commit_message>
<xml_diff>
--- a/content/presentations/HPR-Class4-Practice-Sessions.pptx
+++ b/content/presentations/HPR-Class4-Practice-Sessions.pptx
@@ -3125,7 +3125,7 @@
       </p:sp>
       <p:pic>
         <p:nvPicPr>
-          <p:cNvPr id="30" name="Session1 Photo 1" descr="session photo"/>
+          <p:cNvPr id="40" name="Session1 Photo 1" descr="session photo"/>
           <p:cNvPicPr>
             <a:picLocks noChangeAspect="1"/>
           </p:cNvPicPr>
@@ -3139,8 +3139,8 @@
         </p:blipFill>
         <p:spPr>
           <a:xfrm>
-            <a:off x="5486400" y="960120"/>
-            <a:ext cx="1527048" cy="1755648"/>
+            <a:off x="5509260" y="960120"/>
+            <a:ext cx="990600" cy="1761067"/>
           </a:xfrm>
           <a:prstGeom prst="rect">
             <a:avLst/>
@@ -3149,7 +3149,7 @@
       </p:pic>
       <p:pic>
         <p:nvPicPr>
-          <p:cNvPr id="31" name="Session1 Photo 2" descr="session photo"/>
+          <p:cNvPr id="41" name="Session1 Photo 2" descr="session photo"/>
           <p:cNvPicPr>
             <a:picLocks noChangeAspect="1"/>
           </p:cNvPicPr>
@@ -3163,8 +3163,8 @@
         </p:blipFill>
         <p:spPr>
           <a:xfrm>
-            <a:off x="7068312" y="960120"/>
-            <a:ext cx="1527048" cy="1755648"/>
+            <a:off x="6545580" y="960120"/>
+            <a:ext cx="990600" cy="1761067"/>
           </a:xfrm>
           <a:prstGeom prst="rect">
             <a:avLst/>
@@ -3173,7 +3173,7 @@
       </p:pic>
       <p:pic>
         <p:nvPicPr>
-          <p:cNvPr id="32" name="Session1 Photo 3" descr="session photo"/>
+          <p:cNvPr id="42" name="Session1 Photo 3" descr="session photo"/>
           <p:cNvPicPr>
             <a:picLocks noChangeAspect="1"/>
           </p:cNvPicPr>
@@ -3187,8 +3187,8 @@
         </p:blipFill>
         <p:spPr>
           <a:xfrm>
-            <a:off x="5486400" y="2770632"/>
-            <a:ext cx="1527048" cy="1755648"/>
+            <a:off x="7581900" y="960120"/>
+            <a:ext cx="990600" cy="1761067"/>
           </a:xfrm>
           <a:prstGeom prst="rect">
             <a:avLst/>
@@ -3197,7 +3197,7 @@
       </p:pic>
       <p:pic>
         <p:nvPicPr>
-          <p:cNvPr id="33" name="Session1 Photo 4" descr="session photo"/>
+          <p:cNvPr id="43" name="Session1 Photo 4" descr="session photo"/>
           <p:cNvPicPr>
             <a:picLocks noChangeAspect="1"/>
           </p:cNvPicPr>
@@ -3211,8 +3211,56 @@
         </p:blipFill>
         <p:spPr>
           <a:xfrm>
-            <a:off x="7068312" y="2770632"/>
-            <a:ext cx="1527048" cy="1755648"/>
+            <a:off x="5509260" y="2765213"/>
+            <a:ext cx="990600" cy="1761067"/>
+          </a:xfrm>
+          <a:prstGeom prst="rect">
+            <a:avLst/>
+          </a:prstGeom>
+        </p:spPr>
+      </p:pic>
+      <p:pic>
+        <p:nvPicPr>
+          <p:cNvPr id="44" name="Session1 Photo 5" descr="session photo"/>
+          <p:cNvPicPr>
+            <a:picLocks noChangeAspect="1"/>
+          </p:cNvPicPr>
+          <p:nvPr/>
+        </p:nvPicPr>
+        <p:blipFill>
+          <a:blip r:embed="rId8"/>
+          <a:stretch>
+            <a:fillRect/>
+          </a:stretch>
+        </p:blipFill>
+        <p:spPr>
+          <a:xfrm>
+            <a:off x="6545580" y="2765213"/>
+            <a:ext cx="990600" cy="1761067"/>
+          </a:xfrm>
+          <a:prstGeom prst="rect">
+            <a:avLst/>
+          </a:prstGeom>
+        </p:spPr>
+      </p:pic>
+      <p:pic>
+        <p:nvPicPr>
+          <p:cNvPr id="45" name="Session1 Photo 6" descr="session photo"/>
+          <p:cNvPicPr>
+            <a:picLocks noChangeAspect="1"/>
+          </p:cNvPicPr>
+          <p:nvPr/>
+        </p:nvPicPr>
+        <p:blipFill>
+          <a:blip r:embed="rId9"/>
+          <a:stretch>
+            <a:fillRect/>
+          </a:stretch>
+        </p:blipFill>
+        <p:spPr>
+          <a:xfrm>
+            <a:off x="7581900" y="2765213"/>
+            <a:ext cx="990600" cy="1761067"/>
           </a:xfrm>
           <a:prstGeom prst="rect">
             <a:avLst/>

</xml_diff>